<commit_message>
Update OPC AI course deck
</commit_message>
<xml_diff>
--- a/docs/OPC-AI公益课-自测评估与成长路径.pptx
+++ b/docs/OPC-AI公益课-自测评估与成长路径.pptx
@@ -36806,8 +36806,18 @@
                         </a:defRPr>
                       </a:pPr>
                       <a:r>
+                        <a:rPr sz="1600">
+                          <a:solidFill>
+                            <a:schemeClr val="bg1"/>
+                          </a:solidFill>
+                        </a:rPr>
                         <a:t>组合状态</a:t>
                       </a:r>
+                      <a:endParaRPr sz="1600">
+                        <a:solidFill>
+                          <a:schemeClr val="bg1"/>
+                        </a:solidFill>
+                      </a:endParaRPr>
                     </a:p>
                   </a:txBody>
                   <a:tcPr marL="54864" marR="54864" marT="36576" marB="36576" anchor="ctr">
@@ -36830,8 +36840,18 @@
                         </a:defRPr>
                       </a:pPr>
                       <a:r>
+                        <a:rPr sz="1600">
+                          <a:solidFill>
+                            <a:schemeClr val="bg1"/>
+                          </a:solidFill>
+                        </a:rPr>
                         <a:t>最适合的启动方向</a:t>
                       </a:r>
+                      <a:endParaRPr sz="1600">
+                        <a:solidFill>
+                          <a:schemeClr val="bg1"/>
+                        </a:solidFill>
+                      </a:endParaRPr>
                     </a:p>
                   </a:txBody>
                   <a:tcPr marL="54864" marR="54864" marT="36576" marB="36576" anchor="ctr">
@@ -36854,8 +36874,18 @@
                         </a:defRPr>
                       </a:pPr>
                       <a:r>
+                        <a:rPr sz="1600">
+                          <a:solidFill>
+                            <a:schemeClr val="bg1"/>
+                          </a:solidFill>
+                        </a:rPr>
                         <a:t>第一份交付物</a:t>
                       </a:r>
+                      <a:endParaRPr sz="1600">
+                        <a:solidFill>
+                          <a:schemeClr val="bg1"/>
+                        </a:solidFill>
+                      </a:endParaRPr>
                     </a:p>
                   </a:txBody>
                   <a:tcPr marL="54864" marR="54864" marT="36576" marB="36576" anchor="ctr">
@@ -36878,8 +36908,18 @@
                         </a:defRPr>
                       </a:pPr>
                       <a:r>
+                        <a:rPr sz="1600">
+                          <a:solidFill>
+                            <a:schemeClr val="bg1"/>
+                          </a:solidFill>
+                        </a:rPr>
                         <a:t>后续服务线索</a:t>
                       </a:r>
+                      <a:endParaRPr sz="1600">
+                        <a:solidFill>
+                          <a:schemeClr val="bg1"/>
+                        </a:solidFill>
+                      </a:endParaRPr>
                     </a:p>
                   </a:txBody>
                   <a:tcPr marL="54864" marR="54864" marT="36576" marB="36576" anchor="ctr">
@@ -36904,8 +36944,18 @@
                         </a:defRPr>
                       </a:pPr>
                       <a:r>
+                        <a:rPr sz="1600">
+                          <a:solidFill>
+                            <a:schemeClr val="bg1"/>
+                          </a:solidFill>
+                        </a:rPr>
                         <a:t>准备低 + AI 低</a:t>
                       </a:r>
+                      <a:endParaRPr sz="1600">
+                        <a:solidFill>
+                          <a:schemeClr val="bg1"/>
+                        </a:solidFill>
+                      </a:endParaRPr>
                     </a:p>
                   </a:txBody>
                   <a:tcPr marL="54864" marR="54864" marT="36576" marB="36576" anchor="ctr">
@@ -36928,8 +36978,18 @@
                         </a:defRPr>
                       </a:pPr>
                       <a:r>
+                        <a:rPr sz="1600">
+                          <a:solidFill>
+                            <a:schemeClr val="bg1"/>
+                          </a:solidFill>
+                        </a:rPr>
                         <a:t>职业提效 / 客户访谈</a:t>
                       </a:r>
+                      <a:endParaRPr sz="1600">
+                        <a:solidFill>
+                          <a:schemeClr val="bg1"/>
+                        </a:solidFill>
+                      </a:endParaRPr>
                     </a:p>
                   </a:txBody>
                   <a:tcPr marL="54864" marR="54864" marT="36576" marB="36576" anchor="ctr">
@@ -36952,8 +37012,18 @@
                         </a:defRPr>
                       </a:pPr>
                       <a:r>
+                        <a:rPr sz="1600">
+                          <a:solidFill>
+                            <a:schemeClr val="bg1"/>
+                          </a:solidFill>
+                        </a:rPr>
                         <a:t>工作流清单 + 10 个访谈问题</a:t>
                       </a:r>
+                      <a:endParaRPr sz="1600">
+                        <a:solidFill>
+                          <a:schemeClr val="bg1"/>
+                        </a:solidFill>
+                      </a:endParaRPr>
                     </a:p>
                   </a:txBody>
                   <a:tcPr marL="54864" marR="54864" marT="36576" marB="36576" anchor="ctr">
@@ -36976,8 +37046,18 @@
                         </a:defRPr>
                       </a:pPr>
                       <a:r>
+                        <a:rPr sz="1600">
+                          <a:solidFill>
+                            <a:schemeClr val="bg1"/>
+                          </a:solidFill>
+                        </a:rPr>
                         <a:t>入门训练营</a:t>
                       </a:r>
+                      <a:endParaRPr sz="1600">
+                        <a:solidFill>
+                          <a:schemeClr val="bg1"/>
+                        </a:solidFill>
+                      </a:endParaRPr>
                     </a:p>
                   </a:txBody>
                   <a:tcPr marL="54864" marR="54864" marT="36576" marB="36576" anchor="ctr">
@@ -37002,8 +37082,18 @@
                         </a:defRPr>
                       </a:pPr>
                       <a:r>
+                        <a:rPr sz="1600">
+                          <a:solidFill>
+                            <a:schemeClr val="bg1"/>
+                          </a:solidFill>
+                        </a:rPr>
                         <a:t>准备中 + AI 中</a:t>
                       </a:r>
+                      <a:endParaRPr sz="1600">
+                        <a:solidFill>
+                          <a:schemeClr val="bg1"/>
+                        </a:solidFill>
+                      </a:endParaRPr>
                     </a:p>
                   </a:txBody>
                   <a:tcPr marL="54864" marR="54864" marT="36576" marB="36576" anchor="ctr">
@@ -37026,8 +37116,18 @@
                         </a:defRPr>
                       </a:pPr>
                       <a:r>
+                        <a:rPr sz="1600">
+                          <a:solidFill>
+                            <a:schemeClr val="bg1"/>
+                          </a:solidFill>
+                        </a:rPr>
                         <a:t>副业验证 / 内容获客</a:t>
                       </a:r>
+                      <a:endParaRPr sz="1600">
+                        <a:solidFill>
+                          <a:schemeClr val="bg1"/>
+                        </a:solidFill>
+                      </a:endParaRPr>
                     </a:p>
                   </a:txBody>
                   <a:tcPr marL="54864" marR="54864" marT="36576" marB="36576" anchor="ctr">
@@ -37050,8 +37150,18 @@
                         </a:defRPr>
                       </a:pPr>
                       <a:r>
+                        <a:rPr sz="1600">
+                          <a:solidFill>
+                            <a:schemeClr val="bg1"/>
+                          </a:solidFill>
+                        </a:rPr>
                         <a:t>30 天验证计划 + 1 个试单方案</a:t>
                       </a:r>
+                      <a:endParaRPr sz="1600">
+                        <a:solidFill>
+                          <a:schemeClr val="bg1"/>
+                        </a:solidFill>
+                      </a:endParaRPr>
                     </a:p>
                   </a:txBody>
                   <a:tcPr marL="54864" marR="54864" marT="36576" marB="36576" anchor="ctr">
@@ -37074,8 +37184,18 @@
                         </a:defRPr>
                       </a:pPr>
                       <a:r>
+                        <a:rPr sz="1600">
+                          <a:solidFill>
+                            <a:schemeClr val="bg1"/>
+                          </a:solidFill>
+                        </a:rPr>
                         <a:t>场景工作坊</a:t>
                       </a:r>
+                      <a:endParaRPr sz="1600">
+                        <a:solidFill>
+                          <a:schemeClr val="bg1"/>
+                        </a:solidFill>
+                      </a:endParaRPr>
                     </a:p>
                   </a:txBody>
                   <a:tcPr marL="54864" marR="54864" marT="36576" marB="36576" anchor="ctr">
@@ -37100,8 +37220,18 @@
                         </a:defRPr>
                       </a:pPr>
                       <a:r>
+                        <a:rPr sz="1600">
+                          <a:solidFill>
+                            <a:schemeClr val="bg1"/>
+                          </a:solidFill>
+                        </a:rPr>
                         <a:t>准备高 + AI 中</a:t>
                       </a:r>
+                      <a:endParaRPr sz="1600">
+                        <a:solidFill>
+                          <a:schemeClr val="bg1"/>
+                        </a:solidFill>
+                      </a:endParaRPr>
                     </a:p>
                   </a:txBody>
                   <a:tcPr marL="54864" marR="54864" marT="36576" marB="36576" anchor="ctr">
@@ -37124,8 +37254,18 @@
                         </a:defRPr>
                       </a:pPr>
                       <a:r>
+                        <a:rPr sz="1600">
+                          <a:solidFill>
+                            <a:schemeClr val="bg1"/>
+                          </a:solidFill>
+                        </a:rPr>
                         <a:t>服务型 OPC</a:t>
                       </a:r>
+                      <a:endParaRPr sz="1600">
+                        <a:solidFill>
+                          <a:schemeClr val="bg1"/>
+                        </a:solidFill>
+                      </a:endParaRPr>
                     </a:p>
                   </a:txBody>
                   <a:tcPr marL="54864" marR="54864" marT="36576" marB="36576" anchor="ctr">
@@ -37148,8 +37288,18 @@
                         </a:defRPr>
                       </a:pPr>
                       <a:r>
+                        <a:rPr sz="1600">
+                          <a:solidFill>
+                            <a:schemeClr val="bg1"/>
+                          </a:solidFill>
+                        </a:rPr>
                         <a:t>服务包 + 报价单 + 交付 SOP</a:t>
                       </a:r>
+                      <a:endParaRPr sz="1600">
+                        <a:solidFill>
+                          <a:schemeClr val="bg1"/>
+                        </a:solidFill>
+                      </a:endParaRPr>
                     </a:p>
                   </a:txBody>
                   <a:tcPr marL="54864" marR="54864" marT="36576" marB="36576" anchor="ctr">
@@ -37172,8 +37322,18 @@
                         </a:defRPr>
                       </a:pPr>
                       <a:r>
+                        <a:rPr sz="1600">
+                          <a:solidFill>
+                            <a:schemeClr val="bg1"/>
+                          </a:solidFill>
+                        </a:rPr>
                         <a:t>咨询陪跑</a:t>
                       </a:r>
+                      <a:endParaRPr sz="1600">
+                        <a:solidFill>
+                          <a:schemeClr val="bg1"/>
+                        </a:solidFill>
+                      </a:endParaRPr>
                     </a:p>
                   </a:txBody>
                   <a:tcPr marL="54864" marR="54864" marT="36576" marB="36576" anchor="ctr">
@@ -37198,8 +37358,18 @@
                         </a:defRPr>
                       </a:pPr>
                       <a:r>
+                        <a:rPr sz="1600">
+                          <a:solidFill>
+                            <a:schemeClr val="bg1"/>
+                          </a:solidFill>
+                        </a:rPr>
                         <a:t>准备中高 + AI 高</a:t>
                       </a:r>
+                      <a:endParaRPr sz="1600">
+                        <a:solidFill>
+                          <a:schemeClr val="bg1"/>
+                        </a:solidFill>
+                      </a:endParaRPr>
                     </a:p>
                   </a:txBody>
                   <a:tcPr marL="54864" marR="54864" marT="36576" marB="36576" anchor="ctr">
@@ -37222,8 +37392,18 @@
                         </a:defRPr>
                       </a:pPr>
                       <a:r>
+                        <a:rPr sz="1600">
+                          <a:solidFill>
+                            <a:schemeClr val="bg1"/>
+                          </a:solidFill>
+                        </a:rPr>
                         <a:t>工具化 / 产品化</a:t>
                       </a:r>
+                      <a:endParaRPr sz="1600">
+                        <a:solidFill>
+                          <a:schemeClr val="bg1"/>
+                        </a:solidFill>
+                      </a:endParaRPr>
                     </a:p>
                   </a:txBody>
                   <a:tcPr marL="54864" marR="54864" marT="36576" marB="36576" anchor="ctr">
@@ -37246,8 +37426,18 @@
                         </a:defRPr>
                       </a:pPr>
                       <a:r>
+                        <a:rPr sz="1600">
+                          <a:solidFill>
+                            <a:schemeClr val="bg1"/>
+                          </a:solidFill>
+                        </a:rPr>
                         <a:t>模板产品 / 小工具 / 付费测试页</a:t>
                       </a:r>
+                      <a:endParaRPr sz="1600">
+                        <a:solidFill>
+                          <a:schemeClr val="bg1"/>
+                        </a:solidFill>
+                      </a:endParaRPr>
                     </a:p>
                   </a:txBody>
                   <a:tcPr marL="54864" marR="54864" marT="36576" marB="36576" anchor="ctr">
@@ -37270,8 +37460,18 @@
                         </a:defRPr>
                       </a:pPr>
                       <a:r>
+                        <a:rPr sz="1600">
+                          <a:solidFill>
+                            <a:schemeClr val="bg1"/>
+                          </a:solidFill>
+                        </a:rPr>
                         <a:t>产品共创</a:t>
                       </a:r>
+                      <a:endParaRPr sz="1600">
+                        <a:solidFill>
+                          <a:schemeClr val="bg1"/>
+                        </a:solidFill>
+                      </a:endParaRPr>
                     </a:p>
                   </a:txBody>
                   <a:tcPr marL="54864" marR="54864" marT="36576" marB="36576" anchor="ctr">
@@ -37296,8 +37496,18 @@
                         </a:defRPr>
                       </a:pPr>
                       <a:r>
+                        <a:rPr sz="1600">
+                          <a:solidFill>
+                            <a:schemeClr val="bg1"/>
+                          </a:solidFill>
+                        </a:rPr>
                         <a:t>准备高 + AI 高</a:t>
                       </a:r>
+                      <a:endParaRPr sz="1600">
+                        <a:solidFill>
+                          <a:schemeClr val="bg1"/>
+                        </a:solidFill>
+                      </a:endParaRPr>
                     </a:p>
                   </a:txBody>
                   <a:tcPr marL="54864" marR="54864" marT="36576" marB="36576" anchor="ctr">
@@ -37320,8 +37530,18 @@
                         </a:defRPr>
                       </a:pPr>
                       <a:r>
+                        <a:rPr sz="1600">
+                          <a:solidFill>
+                            <a:schemeClr val="bg1"/>
+                          </a:solidFill>
+                        </a:rPr>
                         <a:t>一人公司系统</a:t>
                       </a:r>
+                      <a:endParaRPr sz="1600">
+                        <a:solidFill>
+                          <a:schemeClr val="bg1"/>
+                        </a:solidFill>
+                      </a:endParaRPr>
                     </a:p>
                   </a:txBody>
                   <a:tcPr marL="54864" marR="54864" marT="36576" marB="36576" anchor="ctr">
@@ -37344,8 +37564,18 @@
                         </a:defRPr>
                       </a:pPr>
                       <a:r>
+                        <a:rPr sz="1600">
+                          <a:solidFill>
+                            <a:schemeClr val="bg1"/>
+                          </a:solidFill>
+                        </a:rPr>
                         <a:t>获客-交付-复盘自动化流程</a:t>
                       </a:r>
+                      <a:endParaRPr sz="1600">
+                        <a:solidFill>
+                          <a:schemeClr val="bg1"/>
+                        </a:solidFill>
+                      </a:endParaRPr>
                     </a:p>
                   </a:txBody>
                   <a:tcPr marL="54864" marR="54864" marT="36576" marB="36576" anchor="ctr">
@@ -37368,8 +37598,18 @@
                         </a:defRPr>
                       </a:pPr>
                       <a:r>
+                        <a:rPr sz="1600">
+                          <a:solidFill>
+                            <a:schemeClr val="bg1"/>
+                          </a:solidFill>
+                        </a:rPr>
                         <a:t>系统搭建</a:t>
                       </a:r>
+                      <a:endParaRPr sz="1600">
+                        <a:solidFill>
+                          <a:schemeClr val="bg1"/>
+                        </a:solidFill>
+                      </a:endParaRPr>
                     </a:p>
                   </a:txBody>
                   <a:tcPr marL="54864" marR="54864" marT="36576" marB="36576" anchor="ctr">
@@ -37383,516 +37623,6 @@
           </a:graphicData>
         </a:graphic>
       </p:graphicFrame>
-      <p:sp>
-        <p:nvSpPr>
-          <p:cNvPr id="41" name="TextBox 40"/>
-          <p:cNvSpPr txBox="1"/>
-          <p:nvPr/>
-        </p:nvSpPr>
-        <p:spPr>
-          <a:xfrm>
-            <a:off x="6720840" y="1353312"/>
-            <a:ext cx="3566160" cy="310896"/>
-          </a:xfrm>
-          <a:prstGeom prst="rect">
-            <a:avLst/>
-          </a:prstGeom>
-          <a:noFill/>
-        </p:spPr>
-        <p:txBody>
-          <a:bodyPr wrap="square" anchor="t">
-            <a:spAutoFit/>
-          </a:bodyPr>
-          <a:lstStyle/>
-          <a:p>
-            <a:pPr algn="l">
-              <a:defRPr sz="1700" b="1">
-                <a:solidFill>
-                  <a:srgbClr val="EEF7FF"/>
-                </a:solidFill>
-                <a:latin typeface="微软雅黑"/>
-              </a:defRPr>
-            </a:pPr>
-            <a:r>
-              <a:t>建议收集 6 类信息</a:t>
-            </a:r>
-          </a:p>
-        </p:txBody>
-      </p:sp>
-      <p:sp>
-        <p:nvSpPr>
-          <p:cNvPr id="42" name="Oval 41"/>
-          <p:cNvSpPr/>
-          <p:nvPr/>
-        </p:nvSpPr>
-        <p:spPr>
-          <a:xfrm>
-            <a:off x="6784848" y="1865376"/>
-            <a:ext cx="146304" cy="146304"/>
-          </a:xfrm>
-          <a:prstGeom prst="ellipse">
-            <a:avLst/>
-          </a:prstGeom>
-          <a:solidFill>
-            <a:srgbClr val="49ECA9"/>
-          </a:solidFill>
-          <a:ln>
-            <a:noFill/>
-          </a:ln>
-        </p:spPr>
-        <p:style>
-          <a:lnRef idx="1">
-            <a:schemeClr val="accent1"/>
-          </a:lnRef>
-          <a:fillRef idx="3">
-            <a:schemeClr val="accent1"/>
-          </a:fillRef>
-          <a:effectRef idx="2">
-            <a:schemeClr val="accent1"/>
-          </a:effectRef>
-          <a:fontRef idx="minor">
-            <a:schemeClr val="lt1"/>
-          </a:fontRef>
-        </p:style>
-        <p:txBody>
-          <a:bodyPr rtlCol="0" anchor="ctr"/>
-          <a:lstStyle/>
-          <a:p>
-            <a:pPr algn="ctr"/>
-          </a:p>
-        </p:txBody>
-      </p:sp>
-      <p:sp>
-        <p:nvSpPr>
-          <p:cNvPr id="43" name="TextBox 42"/>
-          <p:cNvSpPr txBox="1"/>
-          <p:nvPr/>
-        </p:nvSpPr>
-        <p:spPr>
-          <a:xfrm>
-            <a:off x="7040880" y="1810512"/>
-            <a:ext cx="4389120" cy="219456"/>
-          </a:xfrm>
-          <a:prstGeom prst="rect">
-            <a:avLst/>
-          </a:prstGeom>
-          <a:noFill/>
-        </p:spPr>
-        <p:txBody>
-          <a:bodyPr wrap="square" anchor="t">
-            <a:spAutoFit/>
-          </a:bodyPr>
-          <a:lstStyle/>
-          <a:p>
-            <a:pPr algn="l">
-              <a:defRPr sz="1020" b="0">
-                <a:solidFill>
-                  <a:srgbClr val="EEF7FF"/>
-                </a:solidFill>
-                <a:latin typeface="微软雅黑"/>
-              </a:defRPr>
-            </a:pPr>
-            <a:r>
-              <a:t>当前职业 / 专业能力</a:t>
-            </a:r>
-          </a:p>
-        </p:txBody>
-      </p:sp>
-      <p:sp>
-        <p:nvSpPr>
-          <p:cNvPr id="44" name="Oval 43"/>
-          <p:cNvSpPr/>
-          <p:nvPr/>
-        </p:nvSpPr>
-        <p:spPr>
-          <a:xfrm>
-            <a:off x="6784848" y="2295144"/>
-            <a:ext cx="146304" cy="146304"/>
-          </a:xfrm>
-          <a:prstGeom prst="ellipse">
-            <a:avLst/>
-          </a:prstGeom>
-          <a:solidFill>
-            <a:srgbClr val="49ECA9"/>
-          </a:solidFill>
-          <a:ln>
-            <a:noFill/>
-          </a:ln>
-        </p:spPr>
-        <p:style>
-          <a:lnRef idx="1">
-            <a:schemeClr val="accent1"/>
-          </a:lnRef>
-          <a:fillRef idx="3">
-            <a:schemeClr val="accent1"/>
-          </a:fillRef>
-          <a:effectRef idx="2">
-            <a:schemeClr val="accent1"/>
-          </a:effectRef>
-          <a:fontRef idx="minor">
-            <a:schemeClr val="lt1"/>
-          </a:fontRef>
-        </p:style>
-        <p:txBody>
-          <a:bodyPr rtlCol="0" anchor="ctr"/>
-          <a:lstStyle/>
-          <a:p>
-            <a:pPr algn="ctr"/>
-          </a:p>
-        </p:txBody>
-      </p:sp>
-      <p:sp>
-        <p:nvSpPr>
-          <p:cNvPr id="45" name="TextBox 44"/>
-          <p:cNvSpPr txBox="1"/>
-          <p:nvPr/>
-        </p:nvSpPr>
-        <p:spPr>
-          <a:xfrm>
-            <a:off x="7040880" y="2240280"/>
-            <a:ext cx="4389120" cy="219456"/>
-          </a:xfrm>
-          <a:prstGeom prst="rect">
-            <a:avLst/>
-          </a:prstGeom>
-          <a:noFill/>
-        </p:spPr>
-        <p:txBody>
-          <a:bodyPr wrap="square" anchor="t">
-            <a:spAutoFit/>
-          </a:bodyPr>
-          <a:lstStyle/>
-          <a:p>
-            <a:pPr algn="l">
-              <a:defRPr sz="1020" b="0">
-                <a:solidFill>
-                  <a:srgbClr val="EEF7FF"/>
-                </a:solidFill>
-                <a:latin typeface="微软雅黑"/>
-              </a:defRPr>
-            </a:pPr>
-            <a:r>
-              <a:t>想服务的人群与痛点</a:t>
-            </a:r>
-          </a:p>
-        </p:txBody>
-      </p:sp>
-      <p:sp>
-        <p:nvSpPr>
-          <p:cNvPr id="46" name="Oval 45"/>
-          <p:cNvSpPr/>
-          <p:nvPr/>
-        </p:nvSpPr>
-        <p:spPr>
-          <a:xfrm>
-            <a:off x="6784848" y="2724912"/>
-            <a:ext cx="146304" cy="146304"/>
-          </a:xfrm>
-          <a:prstGeom prst="ellipse">
-            <a:avLst/>
-          </a:prstGeom>
-          <a:solidFill>
-            <a:srgbClr val="49ECA9"/>
-          </a:solidFill>
-          <a:ln>
-            <a:noFill/>
-          </a:ln>
-        </p:spPr>
-        <p:style>
-          <a:lnRef idx="1">
-            <a:schemeClr val="accent1"/>
-          </a:lnRef>
-          <a:fillRef idx="3">
-            <a:schemeClr val="accent1"/>
-          </a:fillRef>
-          <a:effectRef idx="2">
-            <a:schemeClr val="accent1"/>
-          </a:effectRef>
-          <a:fontRef idx="minor">
-            <a:schemeClr val="lt1"/>
-          </a:fontRef>
-        </p:style>
-        <p:txBody>
-          <a:bodyPr rtlCol="0" anchor="ctr"/>
-          <a:lstStyle/>
-          <a:p>
-            <a:pPr algn="ctr"/>
-          </a:p>
-        </p:txBody>
-      </p:sp>
-      <p:sp>
-        <p:nvSpPr>
-          <p:cNvPr id="47" name="TextBox 46"/>
-          <p:cNvSpPr txBox="1"/>
-          <p:nvPr/>
-        </p:nvSpPr>
-        <p:spPr>
-          <a:xfrm>
-            <a:off x="7040880" y="2670048"/>
-            <a:ext cx="4389120" cy="219456"/>
-          </a:xfrm>
-          <a:prstGeom prst="rect">
-            <a:avLst/>
-          </a:prstGeom>
-          <a:noFill/>
-        </p:spPr>
-        <p:txBody>
-          <a:bodyPr wrap="square" anchor="t">
-            <a:spAutoFit/>
-          </a:bodyPr>
-          <a:lstStyle/>
-          <a:p>
-            <a:pPr algn="l">
-              <a:defRPr sz="1020" b="0">
-                <a:solidFill>
-                  <a:srgbClr val="EEF7FF"/>
-                </a:solidFill>
-                <a:latin typeface="微软雅黑"/>
-              </a:defRPr>
-            </a:pPr>
-            <a:r>
-              <a:t>每周可投入时间</a:t>
-            </a:r>
-          </a:p>
-        </p:txBody>
-      </p:sp>
-      <p:sp>
-        <p:nvSpPr>
-          <p:cNvPr id="48" name="Oval 47"/>
-          <p:cNvSpPr/>
-          <p:nvPr/>
-        </p:nvSpPr>
-        <p:spPr>
-          <a:xfrm>
-            <a:off x="6784848" y="3154680"/>
-            <a:ext cx="146304" cy="146304"/>
-          </a:xfrm>
-          <a:prstGeom prst="ellipse">
-            <a:avLst/>
-          </a:prstGeom>
-          <a:solidFill>
-            <a:srgbClr val="49ECA9"/>
-          </a:solidFill>
-          <a:ln>
-            <a:noFill/>
-          </a:ln>
-        </p:spPr>
-        <p:style>
-          <a:lnRef idx="1">
-            <a:schemeClr val="accent1"/>
-          </a:lnRef>
-          <a:fillRef idx="3">
-            <a:schemeClr val="accent1"/>
-          </a:fillRef>
-          <a:effectRef idx="2">
-            <a:schemeClr val="accent1"/>
-          </a:effectRef>
-          <a:fontRef idx="minor">
-            <a:schemeClr val="lt1"/>
-          </a:fontRef>
-        </p:style>
-        <p:txBody>
-          <a:bodyPr rtlCol="0" anchor="ctr"/>
-          <a:lstStyle/>
-          <a:p>
-            <a:pPr algn="ctr"/>
-          </a:p>
-        </p:txBody>
-      </p:sp>
-      <p:sp>
-        <p:nvSpPr>
-          <p:cNvPr id="49" name="TextBox 48"/>
-          <p:cNvSpPr txBox="1"/>
-          <p:nvPr/>
-        </p:nvSpPr>
-        <p:spPr>
-          <a:xfrm>
-            <a:off x="7040880" y="3099816"/>
-            <a:ext cx="4389120" cy="219456"/>
-          </a:xfrm>
-          <a:prstGeom prst="rect">
-            <a:avLst/>
-          </a:prstGeom>
-          <a:noFill/>
-        </p:spPr>
-        <p:txBody>
-          <a:bodyPr wrap="square" anchor="t">
-            <a:spAutoFit/>
-          </a:bodyPr>
-          <a:lstStyle/>
-          <a:p>
-            <a:pPr algn="l">
-              <a:defRPr sz="1020" b="0">
-                <a:solidFill>
-                  <a:srgbClr val="EEF7FF"/>
-                </a:solidFill>
-                <a:latin typeface="微软雅黑"/>
-              </a:defRPr>
-            </a:pPr>
-            <a:r>
-              <a:t>可接受投入预算</a:t>
-            </a:r>
-          </a:p>
-        </p:txBody>
-      </p:sp>
-      <p:sp>
-        <p:nvSpPr>
-          <p:cNvPr id="50" name="Oval 49"/>
-          <p:cNvSpPr/>
-          <p:nvPr/>
-        </p:nvSpPr>
-        <p:spPr>
-          <a:xfrm>
-            <a:off x="6784848" y="3584448"/>
-            <a:ext cx="146304" cy="146304"/>
-          </a:xfrm>
-          <a:prstGeom prst="ellipse">
-            <a:avLst/>
-          </a:prstGeom>
-          <a:solidFill>
-            <a:srgbClr val="49ECA9"/>
-          </a:solidFill>
-          <a:ln>
-            <a:noFill/>
-          </a:ln>
-        </p:spPr>
-        <p:style>
-          <a:lnRef idx="1">
-            <a:schemeClr val="accent1"/>
-          </a:lnRef>
-          <a:fillRef idx="3">
-            <a:schemeClr val="accent1"/>
-          </a:fillRef>
-          <a:effectRef idx="2">
-            <a:schemeClr val="accent1"/>
-          </a:effectRef>
-          <a:fontRef idx="minor">
-            <a:schemeClr val="lt1"/>
-          </a:fontRef>
-        </p:style>
-        <p:txBody>
-          <a:bodyPr rtlCol="0" anchor="ctr"/>
-          <a:lstStyle/>
-          <a:p>
-            <a:pPr algn="ctr"/>
-          </a:p>
-        </p:txBody>
-      </p:sp>
-      <p:sp>
-        <p:nvSpPr>
-          <p:cNvPr id="51" name="TextBox 50"/>
-          <p:cNvSpPr txBox="1"/>
-          <p:nvPr/>
-        </p:nvSpPr>
-        <p:spPr>
-          <a:xfrm>
-            <a:off x="7040880" y="3529584"/>
-            <a:ext cx="4389120" cy="219456"/>
-          </a:xfrm>
-          <a:prstGeom prst="rect">
-            <a:avLst/>
-          </a:prstGeom>
-          <a:noFill/>
-        </p:spPr>
-        <p:txBody>
-          <a:bodyPr wrap="square" anchor="t">
-            <a:spAutoFit/>
-          </a:bodyPr>
-          <a:lstStyle/>
-          <a:p>
-            <a:pPr algn="l">
-              <a:defRPr sz="1020" b="0">
-                <a:solidFill>
-                  <a:srgbClr val="EEF7FF"/>
-                </a:solidFill>
-                <a:latin typeface="微软雅黑"/>
-              </a:defRPr>
-            </a:pPr>
-            <a:r>
-              <a:t>已有渠道或私域规模</a:t>
-            </a:r>
-          </a:p>
-        </p:txBody>
-      </p:sp>
-      <p:sp>
-        <p:nvSpPr>
-          <p:cNvPr id="52" name="Oval 51"/>
-          <p:cNvSpPr/>
-          <p:nvPr/>
-        </p:nvSpPr>
-        <p:spPr>
-          <a:xfrm>
-            <a:off x="6784848" y="4014215"/>
-            <a:ext cx="146304" cy="146304"/>
-          </a:xfrm>
-          <a:prstGeom prst="ellipse">
-            <a:avLst/>
-          </a:prstGeom>
-          <a:solidFill>
-            <a:srgbClr val="49ECA9"/>
-          </a:solidFill>
-          <a:ln>
-            <a:noFill/>
-          </a:ln>
-        </p:spPr>
-        <p:style>
-          <a:lnRef idx="1">
-            <a:schemeClr val="accent1"/>
-          </a:lnRef>
-          <a:fillRef idx="3">
-            <a:schemeClr val="accent1"/>
-          </a:fillRef>
-          <a:effectRef idx="2">
-            <a:schemeClr val="accent1"/>
-          </a:effectRef>
-          <a:fontRef idx="minor">
-            <a:schemeClr val="lt1"/>
-          </a:fontRef>
-        </p:style>
-        <p:txBody>
-          <a:bodyPr rtlCol="0" anchor="ctr"/>
-          <a:lstStyle/>
-          <a:p>
-            <a:pPr algn="ctr"/>
-          </a:p>
-        </p:txBody>
-      </p:sp>
-      <p:sp>
-        <p:nvSpPr>
-          <p:cNvPr id="53" name="TextBox 52"/>
-          <p:cNvSpPr txBox="1"/>
-          <p:nvPr/>
-        </p:nvSpPr>
-        <p:spPr>
-          <a:xfrm>
-            <a:off x="7040880" y="3959351"/>
-            <a:ext cx="4389120" cy="219456"/>
-          </a:xfrm>
-          <a:prstGeom prst="rect">
-            <a:avLst/>
-          </a:prstGeom>
-          <a:noFill/>
-        </p:spPr>
-        <p:txBody>
-          <a:bodyPr wrap="square" anchor="t">
-            <a:spAutoFit/>
-          </a:bodyPr>
-          <a:lstStyle/>
-          <a:p>
-            <a:pPr algn="l">
-              <a:defRPr sz="1020" b="0">
-                <a:solidFill>
-                  <a:srgbClr val="EEF7FF"/>
-                </a:solidFill>
-                <a:latin typeface="微软雅黑"/>
-              </a:defRPr>
-            </a:pPr>
-            <a:r>
-              <a:t>最想尝试的 AI 场景</a:t>
-            </a:r>
-          </a:p>
-        </p:txBody>
-      </p:sp>
     </p:spTree>
   </p:cSld>
   <p:clrMapOvr>

</xml_diff>